<commit_message>
modified lab1-for testing aws airflow
</commit_message>
<xml_diff>
--- a/DiagramDrawing.pptx
+++ b/DiagramDrawing.pptx
@@ -5,14 +5,15 @@
     <p:sldMasterId id="2147483648" r:id="rId1"/>
   </p:sldMasterIdLst>
   <p:notesMasterIdLst>
-    <p:notesMasterId r:id="rId4"/>
+    <p:notesMasterId r:id="rId5"/>
   </p:notesMasterIdLst>
   <p:sldIdLst>
     <p:sldId id="257" r:id="rId2"/>
     <p:sldId id="258" r:id="rId3"/>
+    <p:sldId id="259" r:id="rId4"/>
   </p:sldIdLst>
   <p:sldSz cx="12192000" cy="6858000"/>
-  <p:notesSz cx="6858000" cy="9144000"/>
+  <p:notesSz cx="6792913" cy="9925050"/>
   <p:defaultTextStyle>
     <a:defPPr>
       <a:defRPr lang="en-US"/>
@@ -151,7 +152,7 @@
         <p:spPr>
           <a:xfrm>
             <a:off x="0" y="0"/>
-            <a:ext cx="2971800" cy="458788"/>
+            <a:ext cx="2943596" cy="497976"/>
           </a:xfrm>
           <a:prstGeom prst="rect">
             <a:avLst/>
@@ -181,8 +182,8 @@
         </p:nvSpPr>
         <p:spPr>
           <a:xfrm>
-            <a:off x="3884613" y="0"/>
-            <a:ext cx="2971800" cy="458788"/>
+            <a:off x="3847745" y="0"/>
+            <a:ext cx="2943596" cy="497976"/>
           </a:xfrm>
           <a:prstGeom prst="rect">
             <a:avLst/>
@@ -216,8 +217,8 @@
         </p:nvSpPr>
         <p:spPr>
           <a:xfrm>
-            <a:off x="685800" y="1143000"/>
-            <a:ext cx="5486400" cy="3086100"/>
+            <a:off x="419100" y="1239838"/>
+            <a:ext cx="5954713" cy="3351212"/>
           </a:xfrm>
           <a:prstGeom prst="rect">
             <a:avLst/>
@@ -249,8 +250,8 @@
         </p:nvSpPr>
         <p:spPr>
           <a:xfrm>
-            <a:off x="685800" y="4400550"/>
-            <a:ext cx="5486400" cy="3600450"/>
+            <a:off x="679292" y="4776431"/>
+            <a:ext cx="5434330" cy="3907988"/>
           </a:xfrm>
           <a:prstGeom prst="rect">
             <a:avLst/>
@@ -308,8 +309,8 @@
         </p:nvSpPr>
         <p:spPr>
           <a:xfrm>
-            <a:off x="0" y="8685213"/>
-            <a:ext cx="2971800" cy="458787"/>
+            <a:off x="0" y="9427076"/>
+            <a:ext cx="2943596" cy="497975"/>
           </a:xfrm>
           <a:prstGeom prst="rect">
             <a:avLst/>
@@ -339,8 +340,8 @@
         </p:nvSpPr>
         <p:spPr>
           <a:xfrm>
-            <a:off x="3884613" y="8685213"/>
-            <a:ext cx="2971800" cy="458787"/>
+            <a:off x="3847745" y="9427076"/>
+            <a:ext cx="2943596" cy="497975"/>
           </a:xfrm>
           <a:prstGeom prst="rect">
             <a:avLst/>
@@ -509,61 +510,6 @@
           <a:bodyPr/>
           <a:lstStyle/>
           <a:p>
-            <a:pPr marL="0" marR="0" lvl="0" indent="0" algn="l" defTabSz="914400" rtl="0" eaLnBrk="1" fontAlgn="auto" latinLnBrk="0" hangingPunct="1">
-              <a:lnSpc>
-                <a:spcPct val="100000"/>
-              </a:lnSpc>
-              <a:spcBef>
-                <a:spcPts val="0"/>
-              </a:spcBef>
-              <a:spcAft>
-                <a:spcPts val="0"/>
-              </a:spcAft>
-              <a:buClrTx/>
-              <a:buSzTx/>
-              <a:buFontTx/>
-              <a:buNone/>
-              <a:tabLst/>
-              <a:defRPr/>
-            </a:pPr>
-            <a:r>
-              <a:rPr lang="en-US" b="1" dirty="0"/>
-              <a:t>Practice list!!</a:t>
-            </a:r>
-          </a:p>
-          <a:p>
-            <a:pPr marL="0" marR="0" lvl="0" indent="0" algn="l" defTabSz="914400" rtl="0" eaLnBrk="1" fontAlgn="auto" latinLnBrk="0" hangingPunct="1">
-              <a:lnSpc>
-                <a:spcPct val="100000"/>
-              </a:lnSpc>
-              <a:spcBef>
-                <a:spcPts val="0"/>
-              </a:spcBef>
-              <a:spcAft>
-                <a:spcPts val="0"/>
-              </a:spcAft>
-              <a:buClrTx/>
-              <a:buSzTx/>
-              <a:buFontTx/>
-              <a:buNone/>
-              <a:tabLst/>
-              <a:defRPr/>
-            </a:pPr>
-            <a:r>
-              <a:rPr lang="en-US" b="1" dirty="0"/>
-              <a:t>1. Practice Pandas coding to </a:t>
-            </a:r>
-            <a:r>
-              <a:rPr lang="en-US" altLang="zh-CN" b="1" dirty="0"/>
-              <a:t>calculate </a:t>
-            </a:r>
-            <a:r>
-              <a:rPr lang="en-US" altLang="zh-CN" b="1" dirty="0" err="1"/>
-              <a:t>kpis</a:t>
-            </a:r>
-            <a:endParaRPr lang="en-US" altLang="zh-CN" b="1" dirty="0"/>
-          </a:p>
-          <a:p>
             <a:endParaRPr lang="en-US" dirty="0"/>
           </a:p>
         </p:txBody>
@@ -654,39 +600,6 @@
             </a:r>
           </a:p>
           <a:p>
-            <a:pPr marL="0" indent="0">
-              <a:buNone/>
-            </a:pPr>
-            <a:r>
-              <a:rPr lang="en-US" b="1" dirty="0"/>
-              <a:t>2. S3 (</a:t>
-            </a:r>
-            <a:r>
-              <a:rPr lang="en-US" b="1" dirty="0" err="1"/>
-              <a:t>read_file</a:t>
-            </a:r>
-            <a:r>
-              <a:rPr lang="en-US" b="1" dirty="0"/>
-              <a:t>, </a:t>
-            </a:r>
-            <a:r>
-              <a:rPr lang="en-US" b="1" dirty="0" err="1"/>
-              <a:t>list_files</a:t>
-            </a:r>
-            <a:r>
-              <a:rPr lang="en-US" b="1" dirty="0"/>
-              <a:t>/read </a:t>
-            </a:r>
-            <a:r>
-              <a:rPr lang="en-US" b="1" dirty="0" err="1"/>
-              <a:t>foler</a:t>
-            </a:r>
-            <a:r>
-              <a:rPr lang="en-US" b="1" dirty="0"/>
-              <a:t>)</a:t>
-            </a:r>
-          </a:p>
-          <a:p>
             <a:pPr marL="0" marR="0" lvl="0" indent="0" algn="l" defTabSz="914400" rtl="0" eaLnBrk="1" fontAlgn="auto" latinLnBrk="0" hangingPunct="1">
               <a:lnSpc>
                 <a:spcPct val="100000"/>
@@ -705,44 +618,66 @@
               <a:defRPr/>
             </a:pPr>
             <a:r>
+              <a:rPr lang="en-US" b="1" dirty="0">
+                <a:sym typeface="Wingdings 2" panose="05020102010507070707" pitchFamily="18" charset="2"/>
+              </a:rPr>
+              <a:t></a:t>
+            </a:r>
+            <a:r>
               <a:rPr lang="en-US" b="1" dirty="0"/>
-              <a:t>3. </a:t>
+              <a:t>1. Practice Pandas coding to </a:t>
+            </a:r>
+            <a:r>
+              <a:rPr lang="en-US" altLang="zh-CN" b="1" dirty="0"/>
+              <a:t>calculate </a:t>
+            </a:r>
+            <a:r>
+              <a:rPr lang="en-US" altLang="zh-CN" b="1" dirty="0" err="1"/>
+              <a:t>kpis</a:t>
+            </a:r>
+            <a:r>
+              <a:rPr lang="en-US" altLang="zh-CN" b="1" dirty="0"/>
+              <a:t> (local-dev)</a:t>
+            </a:r>
+            <a:endParaRPr lang="en-US" b="1" dirty="0"/>
+          </a:p>
+          <a:p>
+            <a:pPr marL="0" indent="0">
+              <a:buNone/>
+            </a:pPr>
+            <a:r>
+              <a:rPr lang="en-US" b="1" dirty="0">
+                <a:sym typeface="Wingdings 2" panose="05020102010507070707" pitchFamily="18" charset="2"/>
+              </a:rPr>
+              <a:t> </a:t>
+            </a:r>
+            <a:r>
+              <a:rPr lang="en-US" b="1" dirty="0"/>
+              <a:t>2. S3 (</a:t>
             </a:r>
             <a:r>
               <a:rPr lang="en-US" b="1" dirty="0" err="1"/>
-              <a:t>Airflow_hook</a:t>
+              <a:t>read_file</a:t>
             </a:r>
             <a:r>
               <a:rPr lang="en-US" b="1" dirty="0"/>
-              <a:t> for Redshift(</a:t>
-            </a:r>
-            <a:r>
-              <a:rPr lang="en-US" sz="1200" b="1" kern="1200" dirty="0" err="1">
-                <a:solidFill>
-                  <a:schemeClr val="tx1"/>
-                </a:solidFill>
-                <a:effectLst/>
-                <a:latin typeface="+mn-lt"/>
-                <a:ea typeface="+mn-ea"/>
-                <a:cs typeface="+mn-cs"/>
-              </a:rPr>
-              <a:t>PostgresHook</a:t>
-            </a:r>
-            <a:r>
-              <a:rPr lang="en-US" sz="1200" b="1" kern="1200" dirty="0">
-                <a:solidFill>
-                  <a:schemeClr val="tx1"/>
-                </a:solidFill>
-                <a:effectLst/>
-                <a:latin typeface="+mn-lt"/>
-                <a:ea typeface="+mn-ea"/>
-                <a:cs typeface="+mn-cs"/>
-              </a:rPr>
-              <a:t>()</a:t>
+              <a:t>, </a:t>
+            </a:r>
+            <a:r>
+              <a:rPr lang="en-US" b="1" dirty="0" err="1"/>
+              <a:t>list_files</a:t>
             </a:r>
             <a:r>
               <a:rPr lang="en-US" b="1" dirty="0"/>
-              <a:t>) to insert data to redshift</a:t>
+              <a:t>/read </a:t>
+            </a:r>
+            <a:r>
+              <a:rPr lang="en-US" b="1" dirty="0" err="1"/>
+              <a:t>foler</a:t>
+            </a:r>
+            <a:r>
+              <a:rPr lang="en-US" b="1" dirty="0"/>
+              <a:t>)</a:t>
             </a:r>
           </a:p>
           <a:p>
@@ -764,8 +699,50 @@
               <a:defRPr/>
             </a:pPr>
             <a:r>
+              <a:rPr lang="en-US" b="1" dirty="0">
+                <a:sym typeface="Wingdings 2" panose="05020102010507070707" pitchFamily="18" charset="2"/>
+              </a:rPr>
+              <a:t></a:t>
+            </a:r>
+            <a:r>
               <a:rPr lang="en-US" b="1" dirty="0"/>
-              <a:t>To-dos for project:</a:t>
+              <a:t>3. </a:t>
+            </a:r>
+            <a:r>
+              <a:rPr lang="en-US" b="1" dirty="0" err="1"/>
+              <a:t>Airflow_hook</a:t>
+            </a:r>
+            <a:r>
+              <a:rPr lang="en-US" b="1" dirty="0"/>
+              <a:t> for Redshift(</a:t>
+            </a:r>
+            <a:r>
+              <a:rPr lang="en-US" sz="1200" b="1" kern="1200" dirty="0" err="1">
+                <a:solidFill>
+                  <a:schemeClr val="tx1"/>
+                </a:solidFill>
+                <a:effectLst/>
+                <a:latin typeface="+mn-lt"/>
+                <a:ea typeface="+mn-ea"/>
+                <a:cs typeface="+mn-cs"/>
+              </a:rPr>
+              <a:t>PostgresHook</a:t>
+            </a:r>
+            <a:r>
+              <a:rPr lang="en-US" sz="1200" b="1" kern="1200" dirty="0">
+                <a:solidFill>
+                  <a:schemeClr val="tx1"/>
+                </a:solidFill>
+                <a:effectLst/>
+                <a:latin typeface="+mn-lt"/>
+                <a:ea typeface="+mn-ea"/>
+                <a:cs typeface="+mn-cs"/>
+              </a:rPr>
+              <a:t>()</a:t>
+            </a:r>
+            <a:r>
+              <a:rPr lang="en-US" b="1" dirty="0"/>
+              <a:t>) to insert data to redshift</a:t>
             </a:r>
           </a:p>
           <a:p>
@@ -788,7 +765,46 @@
             </a:pPr>
             <a:r>
               <a:rPr lang="en-US" b="1" dirty="0"/>
-              <a:t>Terraform infrastructure: s3 bucket, redshift tables</a:t>
+              <a:t>To-dos for project:</a:t>
+            </a:r>
+          </a:p>
+          <a:p>
+            <a:pPr marL="0" marR="0" lvl="0" indent="0" algn="l" defTabSz="914400" rtl="0" eaLnBrk="1" fontAlgn="auto" latinLnBrk="0" hangingPunct="1">
+              <a:lnSpc>
+                <a:spcPct val="100000"/>
+              </a:lnSpc>
+              <a:spcBef>
+                <a:spcPts val="0"/>
+              </a:spcBef>
+              <a:spcAft>
+                <a:spcPts val="0"/>
+              </a:spcAft>
+              <a:buClrTx/>
+              <a:buSzTx/>
+              <a:buFontTx/>
+              <a:buNone/>
+              <a:tabLst/>
+              <a:defRPr/>
+            </a:pPr>
+            <a:r>
+              <a:rPr lang="en-US" b="1" dirty="0">
+                <a:sym typeface="Wingdings 2" panose="05020102010507070707" pitchFamily="18" charset="2"/>
+              </a:rPr>
+              <a:t></a:t>
+            </a:r>
+            <a:r>
+              <a:rPr lang="en-US" b="1" dirty="0"/>
+              <a:t>Terraform infrastructure: s3 bucket </a:t>
+            </a:r>
+            <a:r>
+              <a:rPr lang="en-US" b="1" dirty="0">
+                <a:sym typeface="Wingdings 2" panose="05020102010507070707" pitchFamily="18" charset="2"/>
+              </a:rPr>
+              <a:t></a:t>
+            </a:r>
+            <a:r>
+              <a:rPr lang="en-US" b="1" dirty="0"/>
+              <a:t>, redshift tables</a:t>
             </a:r>
           </a:p>
         </p:txBody>
@@ -4102,7 +4118,7 @@
         <p:spPr>
           <a:xfrm>
             <a:off x="304799" y="215153"/>
-            <a:ext cx="2408865" cy="369332"/>
+            <a:ext cx="2521331" cy="369332"/>
           </a:xfrm>
           <a:prstGeom prst="rect">
             <a:avLst/>
@@ -4117,16 +4133,13 @@
           <a:p>
             <a:r>
               <a:rPr lang="en-US" b="1" dirty="0"/>
-              <a:t>Data </a:t>
+              <a:t>Lab1: Datasets </a:t>
             </a:r>
             <a:r>
               <a:rPr lang="en-US" altLang="zh-CN" b="1" dirty="0"/>
               <a:t>Structure</a:t>
             </a:r>
-            <a:r>
-              <a:rPr lang="en-US" b="1" dirty="0"/>
-              <a:t> for Lab1</a:t>
-            </a:r>
+            <a:endParaRPr lang="en-US" b="1" dirty="0"/>
           </a:p>
         </p:txBody>
       </p:sp>
@@ -4747,7 +4760,7 @@
         <p:spPr>
           <a:xfrm>
             <a:off x="304799" y="215153"/>
-            <a:ext cx="3458447" cy="369332"/>
+            <a:ext cx="5333383" cy="369332"/>
           </a:xfrm>
           <a:prstGeom prst="rect">
             <a:avLst/>
@@ -4762,7 +4775,7 @@
           <a:p>
             <a:r>
               <a:rPr lang="en-US" altLang="zh-CN" b="1" dirty="0"/>
-              <a:t>DAG Code Structure and data flow</a:t>
+              <a:t>Lab1: Airflow DAG Visual Dataflow and code structure</a:t>
             </a:r>
             <a:endParaRPr lang="en-US" b="1" dirty="0"/>
           </a:p>
@@ -5249,8 +5262,8 @@
         </p:nvSpPr>
         <p:spPr>
           <a:xfrm>
-            <a:off x="304798" y="3369841"/>
-            <a:ext cx="3222173" cy="1323439"/>
+            <a:off x="304797" y="3369841"/>
+            <a:ext cx="3576735" cy="1323439"/>
           </a:xfrm>
           <a:prstGeom prst="rect">
             <a:avLst/>
@@ -5300,7 +5313,7 @@
                   <a:srgbClr val="00B050"/>
                 </a:solidFill>
               </a:rPr>
-              <a:t>2.Check validation results</a:t>
+              <a:t>2.Check validation results match</a:t>
             </a:r>
           </a:p>
         </p:txBody>
@@ -5769,7 +5782,7 @@
         </p:nvSpPr>
         <p:spPr>
           <a:xfrm>
-            <a:off x="4049486" y="3686833"/>
+            <a:off x="4220509" y="3667523"/>
             <a:ext cx="460382" cy="369332"/>
           </a:xfrm>
           <a:prstGeom prst="rect">
@@ -5905,6 +5918,36 @@
     <p:extLst>
       <p:ext uri="{BB962C8B-B14F-4D97-AF65-F5344CB8AC3E}">
         <p14:creationId xmlns:p14="http://schemas.microsoft.com/office/powerpoint/2010/main" val="3560424623"/>
+      </p:ext>
+    </p:extLst>
+  </p:cSld>
+  <p:clrMapOvr>
+    <a:masterClrMapping/>
+  </p:clrMapOvr>
+</p:sld>
+</file>
+
+<file path=ppt/slides/slide3.xml><?xml version="1.0" encoding="utf-8"?>
+<p:sld xmlns:a="http://schemas.openxmlformats.org/drawingml/2006/main" xmlns:r="http://schemas.openxmlformats.org/officeDocument/2006/relationships" xmlns:p="http://schemas.openxmlformats.org/presentationml/2006/main">
+  <p:cSld>
+    <p:spTree>
+      <p:nvGrpSpPr>
+        <p:cNvPr id="1" name=""/>
+        <p:cNvGrpSpPr/>
+        <p:nvPr/>
+      </p:nvGrpSpPr>
+      <p:grpSpPr>
+        <a:xfrm>
+          <a:off x="0" y="0"/>
+          <a:ext cx="0" cy="0"/>
+          <a:chOff x="0" y="0"/>
+          <a:chExt cx="0" cy="0"/>
+        </a:xfrm>
+      </p:grpSpPr>
+    </p:spTree>
+    <p:extLst>
+      <p:ext uri="{BB962C8B-B14F-4D97-AF65-F5344CB8AC3E}">
+        <p14:creationId xmlns:p14="http://schemas.microsoft.com/office/powerpoint/2010/main" val="1240793600"/>
       </p:ext>
     </p:extLst>
   </p:cSld>

</xml_diff>